<commit_message>
Groq primary + Gemini fallback, FAISS vector DB with bge embeddings and reranking
- structure-aware chunking with contextual headers and clause-range citations
- hybrid BM25 + FAISS retrieval fused by RRF, batch metadata filter, cross-encoder rerank
- abstention gate on absolute rerank score, calibrated with zero false refusals
- Groq gpt-oss-120b -> gpt-oss-20b -> Gemini router with token-window throttle
- latency excludes rate-limit waits; provider recorded per answer

Co-Authored-By: Claude Opus 5.5 <noreply@anthropic.com>
</commit_message>
<xml_diff>
--- a/report/AI_Academic_Advisor_Presentation.pptx
+++ b/report/AI_Academic_Advisor_Presentation.pptx
@@ -868,7 +868,7 @@
           <a:lstStyle/>
           <a:p>
             <a:r>
-              <a:t>The abstention bug is worth dwelling on — it is the subtlest engineering point.</a:t>
+              <a:t>The abstention point is the subtlest engineering decision — worth explaining.</a:t>
             </a:r>
           </a:p>
         </p:txBody>
@@ -5744,7 +5744,7 @@
               </a:defRPr>
             </a:pPr>
             <a:r>
-              <a:t>• No cross-encoder reranker (free-tier quota); source correctness could go higher.</a:t>
+              <a:t>• Groq free tier: 200K tokens/day — fallback answers come from a different model.</a:t>
             </a:r>
           </a:p>
           <a:p>
@@ -6807,7 +6807,7 @@
               </a:defRPr>
             </a:pPr>
             <a:r>
-              <a:t>• Student Handbook (Aug 2026, 92 pp) + SOP (17 Aug 2026) → 438 cited passages</a:t>
+              <a:t>• Student Handbook (Aug 2026, 92 pp) + SOP (17 Aug 2026) → 407 cited passages</a:t>
             </a:r>
           </a:p>
           <a:p>
@@ -6882,7 +6882,7 @@
               </a:defRPr>
             </a:pPr>
             <a:r>
-              <a:t>– Clause-aware chunking matters: without it a Section 12 passage inherits Clause 11.5.7's citation, and every source attribution built on it is wrong.</a:t>
+              <a:t>– Structure-aware chunking matters: a fixed-size chunker let a Section 12 passage inherit Clause 11.5.7's citation. Citations now carry clause ranges: “Clause 7–7.2, p.29”.</a:t>
             </a:r>
           </a:p>
         </p:txBody>
@@ -7144,6 +7144,18 @@
               <a:t>Architecture</a:t>
             </a:r>
           </a:p>
+          <a:p>
+            <a:pPr>
+              <a:defRPr sz="1400">
+                <a:solidFill>
+                  <a:srgbClr val="555A60"/>
+                </a:solidFill>
+              </a:defRPr>
+            </a:pPr>
+            <a:r>
+              <a:t>Retrieval + rule engine + model router</a:t>
+            </a:r>
+          </a:p>
         </p:txBody>
       </p:sp>
       <p:sp>
@@ -7222,7 +7234,7 @@
               </a:defRPr>
             </a:pPr>
             <a:r>
-              <a:t>• INGEST → PDF to clause-cited chunks; XLSX to course catalogue, baskets, minors</a:t>
+              <a:t>• CHUNK → structure-aware: one clause per block, packed within the same top-level clause (≤ ~300 tokens), contents pages dropped, contextual header embedded with each chunk</a:t>
             </a:r>
           </a:p>
           <a:p>
@@ -7237,7 +7249,7 @@
               </a:defRPr>
             </a:pPr>
             <a:r>
-              <a:t>• RETRIEVE → BM25 ⊕ dense embeddings, min-max fused</a:t>
+              <a:t>• EMBED → BAAI/bge-small-en-v1.5 sentence transformer (384-d), runs locally</a:t>
             </a:r>
           </a:p>
           <a:p>
@@ -7252,7 +7264,52 @@
               </a:defRPr>
             </a:pPr>
             <a:r>
-              <a:t>• ABSTAIN → on ABSOLUTE scores, not the fused score</a:t>
+              <a:t>• STORE → FAISS IndexFlatIP vector database (exact cosine), persisted to disk</a:t>
+            </a:r>
+          </a:p>
+          <a:p>
+            <a:pPr>
+              <a:spcAft>
+                <a:spcPts val="900"/>
+              </a:spcAft>
+              <a:defRPr sz="1900">
+                <a:solidFill>
+                  <a:srgbClr val="1F3353"/>
+                </a:solidFill>
+              </a:defRPr>
+            </a:pPr>
+            <a:r>
+              <a:t>• RETRIEVE → BM25 + FAISS, fused by Reciprocal Rank Fusion, filtered to the student's batch</a:t>
+            </a:r>
+          </a:p>
+          <a:p>
+            <a:pPr>
+              <a:spcAft>
+                <a:spcPts val="900"/>
+              </a:spcAft>
+              <a:defRPr sz="1900">
+                <a:solidFill>
+                  <a:srgbClr val="1F3353"/>
+                </a:solidFill>
+              </a:defRPr>
+            </a:pPr>
+            <a:r>
+              <a:t>• RERANK → cross-encoder ms-marco-MiniLM-L-6-v2, top-20 → top-4</a:t>
+            </a:r>
+          </a:p>
+          <a:p>
+            <a:pPr>
+              <a:spcAft>
+                <a:spcPts val="900"/>
+              </a:spcAft>
+              <a:defRPr sz="1900">
+                <a:solidFill>
+                  <a:srgbClr val="1F3353"/>
+                </a:solidFill>
+              </a:defRPr>
+            </a:pPr>
+            <a:r>
+              <a:t>• ABSTAIN → gate on the cross-encoder's ABSOLUTE score; below the calibrated threshold the model is never called</a:t>
             </a:r>
           </a:p>
           <a:p>
@@ -7267,29 +7324,14 @@
               </a:defRPr>
             </a:pPr>
             <a:r>
-              <a:t>– Min-max normalisation always forces the top hit to 1.0 — so the ranked score can never say “nothing here”. Abstention uses raw cosine + query-term coverage instead.</a:t>
-            </a:r>
-          </a:p>
-          <a:p>
-            <a:pPr lvl="1">
+              <a:t>– A min-max fused score always rates the best hit 1.0 — it can never say “nothing here”.</a:t>
+            </a:r>
+          </a:p>
+          <a:p>
+            <a:pPr>
               <a:spcAft>
                 <a:spcPts val="900"/>
               </a:spcAft>
-              <a:defRPr sz="1600">
-                <a:solidFill>
-                  <a:srgbClr val="555A60"/>
-                </a:solidFill>
-              </a:defRPr>
-            </a:pPr>
-            <a:r>
-              <a:t>– When both are weak the system returns INSUFFICIENT INFORMATION without calling the model at all — a generation step there can only hallucinate.</a:t>
-            </a:r>
-          </a:p>
-          <a:p>
-            <a:pPr>
-              <a:spcAft>
-                <a:spcPts val="900"/>
-              </a:spcAft>
               <a:defRPr sz="1900">
                 <a:solidFill>
                   <a:srgbClr val="1F3353"/>
@@ -7297,22 +7339,7 @@
               </a:defRPr>
             </a:pPr>
             <a:r>
-              <a:t>• REASON → rule engine computes eligibility; conflict detector flags contradictions</a:t>
-            </a:r>
-          </a:p>
-          <a:p>
-            <a:pPr>
-              <a:spcAft>
-                <a:spcPts val="900"/>
-              </a:spcAft>
-              <a:defRPr sz="1900">
-                <a:solidFill>
-                  <a:srgbClr val="1F3353"/>
-                </a:solidFill>
-              </a:defRPr>
-            </a:pPr>
-            <a:r>
-              <a:t>• GENERATE → Gemini 2.0 Flash, temperature 0, output contract ANSWER · EVIDENCE · CONFIDENCE · FOLLOW-UP</a:t>
+              <a:t>• GENERATE → Groq gpt-oss-120b → gpt-oss-20b → Gemini 3.6 Flash fallback, temperature 0</a:t>
             </a:r>
           </a:p>
         </p:txBody>

</xml_diff>